<commit_message>
Rebuild PDF and visuals for commercialization + P23
Add commercial bands, resource-envelope, and freeze-amortize posters;
expand visual PPTX to 13 slides; add editorial commercialization slide;
regenerate English survey PDF including §5.7.

Co-authored-by: zackc6 <zackc6@users.noreply.github.com>
</commit_message>
<xml_diff>
--- a/publish/out/next-gen-ai-compiler-survey-visual.pptx
+++ b/publish/out/next-gen-ai-compiler-survey-visual.pptx
@@ -15,6 +15,9 @@
     <p:sldId id="263" r:id="rId14"/>
     <p:sldId id="264" r:id="rId15"/>
     <p:sldId id="265" r:id="rId16"/>
+    <p:sldId id="266" r:id="rId17"/>
+    <p:sldId id="267" r:id="rId18"/>
+    <p:sldId id="268" r:id="rId19"/>
   </p:sldIdLst>
   <p:sldSz cx="12191695" cy="6858000" type="screen4x3"/>
   <p:notesSz cx="6858000" cy="9144000"/>
@@ -3142,6 +3145,132 @@
       <p:pic>
         <p:nvPicPr>
           <p:cNvPr id="2" name="Picture 1" descr="10-falsifiers.png"/>
+          <p:cNvPicPr>
+            <a:picLocks noChangeAspect="1"/>
+          </p:cNvPicPr>
+          <p:nvPr/>
+        </p:nvPicPr>
+        <p:blipFill>
+          <a:blip r:embed="rId2"/>
+          <a:stretch>
+            <a:fillRect/>
+          </a:stretch>
+        </p:blipFill>
+        <p:spPr>
+          <a:xfrm>
+            <a:off x="0" y="0"/>
+            <a:ext cx="12191695" cy="6858000"/>
+          </a:xfrm>
+          <a:prstGeom prst="rect">
+            <a:avLst/>
+          </a:prstGeom>
+        </p:spPr>
+      </p:pic>
+    </p:spTree>
+  </p:cSld>
+  <p:clrMapOvr>
+    <a:masterClrMapping/>
+  </p:clrMapOvr>
+</p:sld>
+</file>
+
+<file path=ppt/slides/slide11.xml><?xml version="1.0" encoding="utf-8"?>
+<p:sld xmlns:a="http://schemas.openxmlformats.org/drawingml/2006/main" xmlns:p="http://schemas.openxmlformats.org/presentationml/2006/main" xmlns:r="http://schemas.openxmlformats.org/officeDocument/2006/relationships">
+  <p:cSld>
+    <p:spTree>
+      <p:nvGrpSpPr>
+        <p:cNvPr id="1" name=""/>
+        <p:cNvGrpSpPr/>
+        <p:nvPr/>
+      </p:nvGrpSpPr>
+      <p:grpSpPr/>
+      <p:pic>
+        <p:nvPicPr>
+          <p:cNvPr id="2" name="Picture 1" descr="11-commercial-bands.png"/>
+          <p:cNvPicPr>
+            <a:picLocks noChangeAspect="1"/>
+          </p:cNvPicPr>
+          <p:nvPr/>
+        </p:nvPicPr>
+        <p:blipFill>
+          <a:blip r:embed="rId2"/>
+          <a:stretch>
+            <a:fillRect/>
+          </a:stretch>
+        </p:blipFill>
+        <p:spPr>
+          <a:xfrm>
+            <a:off x="0" y="0"/>
+            <a:ext cx="12191695" cy="6858000"/>
+          </a:xfrm>
+          <a:prstGeom prst="rect">
+            <a:avLst/>
+          </a:prstGeom>
+        </p:spPr>
+      </p:pic>
+    </p:spTree>
+  </p:cSld>
+  <p:clrMapOvr>
+    <a:masterClrMapping/>
+  </p:clrMapOvr>
+</p:sld>
+</file>
+
+<file path=ppt/slides/slide12.xml><?xml version="1.0" encoding="utf-8"?>
+<p:sld xmlns:a="http://schemas.openxmlformats.org/drawingml/2006/main" xmlns:p="http://schemas.openxmlformats.org/presentationml/2006/main" xmlns:r="http://schemas.openxmlformats.org/officeDocument/2006/relationships">
+  <p:cSld>
+    <p:spTree>
+      <p:nvGrpSpPr>
+        <p:cNvPr id="1" name=""/>
+        <p:cNvGrpSpPr/>
+        <p:nvPr/>
+      </p:nvGrpSpPr>
+      <p:grpSpPr/>
+      <p:pic>
+        <p:nvPicPr>
+          <p:cNvPr id="2" name="Picture 1" descr="12-resource-envelope.png"/>
+          <p:cNvPicPr>
+            <a:picLocks noChangeAspect="1"/>
+          </p:cNvPicPr>
+          <p:nvPr/>
+        </p:nvPicPr>
+        <p:blipFill>
+          <a:blip r:embed="rId2"/>
+          <a:stretch>
+            <a:fillRect/>
+          </a:stretch>
+        </p:blipFill>
+        <p:spPr>
+          <a:xfrm>
+            <a:off x="0" y="0"/>
+            <a:ext cx="12191695" cy="6858000"/>
+          </a:xfrm>
+          <a:prstGeom prst="rect">
+            <a:avLst/>
+          </a:prstGeom>
+        </p:spPr>
+      </p:pic>
+    </p:spTree>
+  </p:cSld>
+  <p:clrMapOvr>
+    <a:masterClrMapping/>
+  </p:clrMapOvr>
+</p:sld>
+</file>
+
+<file path=ppt/slides/slide13.xml><?xml version="1.0" encoding="utf-8"?>
+<p:sld xmlns:a="http://schemas.openxmlformats.org/drawingml/2006/main" xmlns:p="http://schemas.openxmlformats.org/presentationml/2006/main" xmlns:r="http://schemas.openxmlformats.org/officeDocument/2006/relationships">
+  <p:cSld>
+    <p:spTree>
+      <p:nvGrpSpPr>
+        <p:cNvPr id="1" name=""/>
+        <p:cNvGrpSpPr/>
+        <p:nvPr/>
+      </p:nvGrpSpPr>
+      <p:grpSpPr/>
+      <p:pic>
+        <p:nvPicPr>
+          <p:cNvPr id="2" name="Picture 1" descr="13-freeze-amortize.png"/>
           <p:cNvPicPr>
             <a:picLocks noChangeAspect="1"/>
           </p:cNvPicPr>

</xml_diff>

<commit_message>
Redraw §5.1 and ROADMAP architecture evolution diagrams
Expand the hybrid stack picture (jobs + substrate → data plane →
codesign) and the Today→Horizon A→B evolution. Add matching visual
posters for architecture and roadmap evolution.

Co-authored-by: zackc6 <zackc6@users.noreply.github.com>
</commit_message>
<xml_diff>
--- a/publish/out/next-gen-ai-compiler-survey-visual.pptx
+++ b/publish/out/next-gen-ai-compiler-survey-visual.pptx
@@ -18,6 +18,7 @@
     <p:sldId id="266" r:id="rId17"/>
     <p:sldId id="267" r:id="rId18"/>
     <p:sldId id="268" r:id="rId19"/>
+    <p:sldId id="269" r:id="rId20"/>
   </p:sldIdLst>
   <p:sldSz cx="12191695" cy="6858000" type="screen4x3"/>
   <p:notesSz cx="6858000" cy="9144000"/>
@@ -3144,7 +3145,7 @@
       <p:grpSpPr/>
       <p:pic>
         <p:nvPicPr>
-          <p:cNvPr id="2" name="Picture 1" descr="10-falsifiers.png"/>
+          <p:cNvPr id="2" name="Picture 1" descr="09-architecture-evolution.png"/>
           <p:cNvPicPr>
             <a:picLocks noChangeAspect="1"/>
           </p:cNvPicPr>
@@ -3186,7 +3187,7 @@
       <p:grpSpPr/>
       <p:pic>
         <p:nvPicPr>
-          <p:cNvPr id="2" name="Picture 1" descr="11-commercial-bands.png"/>
+          <p:cNvPr id="2" name="Picture 1" descr="10-falsifiers.png"/>
           <p:cNvPicPr>
             <a:picLocks noChangeAspect="1"/>
           </p:cNvPicPr>
@@ -3228,6 +3229,48 @@
       <p:grpSpPr/>
       <p:pic>
         <p:nvPicPr>
+          <p:cNvPr id="2" name="Picture 1" descr="11-commercial-bands.png"/>
+          <p:cNvPicPr>
+            <a:picLocks noChangeAspect="1"/>
+          </p:cNvPicPr>
+          <p:nvPr/>
+        </p:nvPicPr>
+        <p:blipFill>
+          <a:blip r:embed="rId2"/>
+          <a:stretch>
+            <a:fillRect/>
+          </a:stretch>
+        </p:blipFill>
+        <p:spPr>
+          <a:xfrm>
+            <a:off x="0" y="0"/>
+            <a:ext cx="12191695" cy="6858000"/>
+          </a:xfrm>
+          <a:prstGeom prst="rect">
+            <a:avLst/>
+          </a:prstGeom>
+        </p:spPr>
+      </p:pic>
+    </p:spTree>
+  </p:cSld>
+  <p:clrMapOvr>
+    <a:masterClrMapping/>
+  </p:clrMapOvr>
+</p:sld>
+</file>
+
+<file path=ppt/slides/slide13.xml><?xml version="1.0" encoding="utf-8"?>
+<p:sld xmlns:a="http://schemas.openxmlformats.org/drawingml/2006/main" xmlns:p="http://schemas.openxmlformats.org/presentationml/2006/main" xmlns:r="http://schemas.openxmlformats.org/officeDocument/2006/relationships">
+  <p:cSld>
+    <p:spTree>
+      <p:nvGrpSpPr>
+        <p:cNvPr id="1" name=""/>
+        <p:cNvGrpSpPr/>
+        <p:nvPr/>
+      </p:nvGrpSpPr>
+      <p:grpSpPr/>
+      <p:pic>
+        <p:nvPicPr>
           <p:cNvPr id="2" name="Picture 1" descr="12-resource-envelope.png"/>
           <p:cNvPicPr>
             <a:picLocks noChangeAspect="1"/>
@@ -3258,7 +3301,7 @@
 </p:sld>
 </file>
 
-<file path=ppt/slides/slide13.xml><?xml version="1.0" encoding="utf-8"?>
+<file path=ppt/slides/slide14.xml><?xml version="1.0" encoding="utf-8"?>
 <p:sld xmlns:a="http://schemas.openxmlformats.org/drawingml/2006/main" xmlns:p="http://schemas.openxmlformats.org/presentationml/2006/main" xmlns:r="http://schemas.openxmlformats.org/officeDocument/2006/relationships">
   <p:cSld>
     <p:spTree>
@@ -3354,7 +3397,7 @@
       <p:grpSpPr/>
       <p:pic>
         <p:nvPicPr>
-          <p:cNvPr id="2" name="Picture 1" descr="03-era-path.png"/>
+          <p:cNvPr id="2" name="Picture 1" descr="02b-architecture-51.png"/>
           <p:cNvPicPr>
             <a:picLocks noChangeAspect="1"/>
           </p:cNvPicPr>
@@ -3396,7 +3439,7 @@
       <p:grpSpPr/>
       <p:pic>
         <p:nvPicPr>
-          <p:cNvPr id="2" name="Picture 1" descr="04-four-jobs-orbit.png"/>
+          <p:cNvPr id="2" name="Picture 1" descr="03-era-path.png"/>
           <p:cNvPicPr>
             <a:picLocks noChangeAspect="1"/>
           </p:cNvPicPr>
@@ -3438,7 +3481,7 @@
       <p:grpSpPr/>
       <p:pic>
         <p:nvPicPr>
-          <p:cNvPr id="2" name="Picture 1" descr="05-stack-pressure.png"/>
+          <p:cNvPr id="2" name="Picture 1" descr="04-four-jobs-orbit.png"/>
           <p:cNvPicPr>
             <a:picLocks noChangeAspect="1"/>
           </p:cNvPicPr>
@@ -3480,7 +3523,7 @@
       <p:grpSpPr/>
       <p:pic>
         <p:nvPicPr>
-          <p:cNvPr id="2" name="Picture 1" descr="06-codesign-ladder.png"/>
+          <p:cNvPr id="2" name="Picture 1" descr="05-stack-pressure.png"/>
           <p:cNvPicPr>
             <a:picLocks noChangeAspect="1"/>
           </p:cNvPicPr>
@@ -3522,7 +3565,7 @@
       <p:grpSpPr/>
       <p:pic>
         <p:nvPicPr>
-          <p:cNvPr id="2" name="Picture 1" descr="07-conflicts-tension.png"/>
+          <p:cNvPr id="2" name="Picture 1" descr="06-codesign-ladder.png"/>
           <p:cNvPicPr>
             <a:picLocks noChangeAspect="1"/>
           </p:cNvPicPr>
@@ -3564,7 +3607,7 @@
       <p:grpSpPr/>
       <p:pic>
         <p:nvPicPr>
-          <p:cNvPr id="2" name="Picture 1" descr="08-vision-constellation.png"/>
+          <p:cNvPr id="2" name="Picture 1" descr="07-conflicts-tension.png"/>
           <p:cNvPicPr>
             <a:picLocks noChangeAspect="1"/>
           </p:cNvPicPr>
@@ -3606,7 +3649,7 @@
       <p:grpSpPr/>
       <p:pic>
         <p:nvPicPr>
-          <p:cNvPr id="2" name="Picture 1" descr="09-two-horizons.png"/>
+          <p:cNvPr id="2" name="Picture 1" descr="08-vision-constellation.png"/>
           <p:cNvPicPr>
             <a:picLocks noChangeAspect="1"/>
           </p:cNvPicPr>

</xml_diff>